<commit_message>
Update Day 1 & Day 2
</commit_message>
<xml_diff>
--- a/Lab Materials/Day 1 - Lab Materials/Activity 1/01_cleaning.pptx
+++ b/Lab Materials/Day 1 - Lab Materials/Activity 1/01_cleaning.pptx
@@ -135,8 +135,7 @@
 <file path=ppt/revisionInfo.xml><?xml version="1.0" encoding="utf-8"?>
 <p1510:revInfo xmlns:a="http://schemas.openxmlformats.org/drawingml/2006/main" xmlns:r="http://schemas.openxmlformats.org/officeDocument/2006/relationships" xmlns:p1510="http://schemas.microsoft.com/office/powerpoint/2015/10/main">
   <p1510:revLst>
-    <p1510:client id="{09C23A66-2653-4861-BDA2-D841B843673E}" v="7" dt="2026-07-19T04:36:26.387"/>
-    <p1510:client id="{48DB55CD-849A-4F60-B88C-613FB3B6ECA4}" v="504" dt="2026-07-18T20:57:40.209"/>
+    <p1510:client id="{67B2A79A-9CA8-4B4E-8461-1A21B581C16F}" v="1" dt="2026-07-21T20:02:21.800"/>
   </p1510:revLst>
 </p1510:revInfo>
 </file>
@@ -146,201 +145,10 @@
   <pc:docChgLst>
     <pc:chgData name="ambleic@clemson.edu" userId="43615028507_tp_box_2" providerId="OAuth2" clId="{5F4B9ABB-DEB5-4DC3-A8F9-1752A2D02C85}"/>
     <pc:docChg chg="undo custSel addSld delSld modSld sldOrd">
-      <pc:chgData name="ambleic@clemson.edu" userId="43615028507_tp_box_2" providerId="OAuth2" clId="{5F4B9ABB-DEB5-4DC3-A8F9-1752A2D02C85}" dt="2026-07-19T04:36:26.387" v="1088" actId="20577"/>
+      <pc:chgData name="ambleic@clemson.edu" userId="43615028507_tp_box_2" providerId="OAuth2" clId="{5F4B9ABB-DEB5-4DC3-A8F9-1752A2D02C85}" dt="2026-07-21T20:02:21.800" v="1089"/>
       <pc:docMkLst>
         <pc:docMk/>
       </pc:docMkLst>
-      <pc:sldChg chg="modSp del mod">
-        <pc:chgData name="ambleic@clemson.edu" userId="43615028507_tp_box_2" providerId="OAuth2" clId="{5F4B9ABB-DEB5-4DC3-A8F9-1752A2D02C85}" dt="2026-07-18T20:21:32.916" v="447"/>
-        <pc:sldMkLst>
-          <pc:docMk/>
-          <pc:sldMk cId="0" sldId="274"/>
-        </pc:sldMkLst>
-        <pc:spChg chg="mod">
-          <ac:chgData name="ambleic@clemson.edu" userId="43615028507_tp_box_2" providerId="OAuth2" clId="{5F4B9ABB-DEB5-4DC3-A8F9-1752A2D02C85}" dt="2026-07-18T20:21:25.607" v="408"/>
-          <ac:spMkLst>
-            <pc:docMk/>
-            <pc:sldMk cId="0" sldId="274"/>
-            <ac:spMk id="30" creationId="{766B9B3D-540A-F916-3ED6-CC73478D77A4}"/>
-          </ac:spMkLst>
-        </pc:spChg>
-        <pc:spChg chg="mod">
-          <ac:chgData name="ambleic@clemson.edu" userId="43615028507_tp_box_2" providerId="OAuth2" clId="{5F4B9ABB-DEB5-4DC3-A8F9-1752A2D02C85}" dt="2026-07-18T20:21:25.607" v="410"/>
-          <ac:spMkLst>
-            <pc:docMk/>
-            <pc:sldMk cId="0" sldId="274"/>
-            <ac:spMk id="31" creationId="{8C277FC5-C822-B3CE-E1DA-8FDCF2402478}"/>
-          </ac:spMkLst>
-        </pc:spChg>
-        <pc:spChg chg="mod">
-          <ac:chgData name="ambleic@clemson.edu" userId="43615028507_tp_box_2" providerId="OAuth2" clId="{5F4B9ABB-DEB5-4DC3-A8F9-1752A2D02C85}" dt="2026-07-18T20:21:25.607" v="409"/>
-          <ac:spMkLst>
-            <pc:docMk/>
-            <pc:sldMk cId="0" sldId="274"/>
-            <ac:spMk id="32" creationId="{97C04A63-A93A-CD73-04A0-135DC454E535}"/>
-          </ac:spMkLst>
-        </pc:spChg>
-        <pc:spChg chg="mod">
-          <ac:chgData name="ambleic@clemson.edu" userId="43615028507_tp_box_2" providerId="OAuth2" clId="{5F4B9ABB-DEB5-4DC3-A8F9-1752A2D02C85}" dt="2026-07-18T20:17:45.319" v="403" actId="255"/>
-          <ac:spMkLst>
-            <pc:docMk/>
-            <pc:sldMk cId="0" sldId="274"/>
-            <ac:spMk id="33" creationId="{28CF86E1-E08C-D421-C3D6-DAC7879757F7}"/>
-          </ac:spMkLst>
-        </pc:spChg>
-        <pc:spChg chg="mod">
-          <ac:chgData name="ambleic@clemson.edu" userId="43615028507_tp_box_2" providerId="OAuth2" clId="{5F4B9ABB-DEB5-4DC3-A8F9-1752A2D02C85}" dt="2026-07-18T20:21:25.607" v="415"/>
-          <ac:spMkLst>
-            <pc:docMk/>
-            <pc:sldMk cId="0" sldId="274"/>
-            <ac:spMk id="34" creationId="{5780BAFF-6D6C-3FE5-DFB5-20F98DEA1C4C}"/>
-          </ac:spMkLst>
-        </pc:spChg>
-        <pc:spChg chg="mod">
-          <ac:chgData name="ambleic@clemson.edu" userId="43615028507_tp_box_2" providerId="OAuth2" clId="{5F4B9ABB-DEB5-4DC3-A8F9-1752A2D02C85}" dt="2026-07-18T20:21:25.612" v="417"/>
-          <ac:spMkLst>
-            <pc:docMk/>
-            <pc:sldMk cId="0" sldId="274"/>
-            <ac:spMk id="35" creationId="{2E695CB8-3A1B-A5D3-1004-94E84B3A4748}"/>
-          </ac:spMkLst>
-        </pc:spChg>
-        <pc:spChg chg="mod">
-          <ac:chgData name="ambleic@clemson.edu" userId="43615028507_tp_box_2" providerId="OAuth2" clId="{5F4B9ABB-DEB5-4DC3-A8F9-1752A2D02C85}" dt="2026-07-18T20:21:25.612" v="416"/>
-          <ac:spMkLst>
-            <pc:docMk/>
-            <pc:sldMk cId="0" sldId="274"/>
-            <ac:spMk id="36" creationId="{7A52337C-FE99-813B-A4A5-1FB3E865C6CD}"/>
-          </ac:spMkLst>
-        </pc:spChg>
-        <pc:spChg chg="mod">
-          <ac:chgData name="ambleic@clemson.edu" userId="43615028507_tp_box_2" providerId="OAuth2" clId="{5F4B9ABB-DEB5-4DC3-A8F9-1752A2D02C85}" dt="2026-07-18T20:21:25.614" v="422"/>
-          <ac:spMkLst>
-            <pc:docMk/>
-            <pc:sldMk cId="0" sldId="274"/>
-            <ac:spMk id="38" creationId="{63767C7F-4C42-88C0-E178-132D80506C59}"/>
-          </ac:spMkLst>
-        </pc:spChg>
-        <pc:spChg chg="mod">
-          <ac:chgData name="ambleic@clemson.edu" userId="43615028507_tp_box_2" providerId="OAuth2" clId="{5F4B9ABB-DEB5-4DC3-A8F9-1752A2D02C85}" dt="2026-07-18T20:21:25.614" v="424"/>
-          <ac:spMkLst>
-            <pc:docMk/>
-            <pc:sldMk cId="0" sldId="274"/>
-            <ac:spMk id="39" creationId="{9C9174C5-5963-7DC6-5E0E-92BB2C7FC0E5}"/>
-          </ac:spMkLst>
-        </pc:spChg>
-        <pc:spChg chg="mod">
-          <ac:chgData name="ambleic@clemson.edu" userId="43615028507_tp_box_2" providerId="OAuth2" clId="{5F4B9ABB-DEB5-4DC3-A8F9-1752A2D02C85}" dt="2026-07-18T20:21:25.614" v="423"/>
-          <ac:spMkLst>
-            <pc:docMk/>
-            <pc:sldMk cId="0" sldId="274"/>
-            <ac:spMk id="40" creationId="{2A076537-A7C2-48BE-3E40-C7F2E897F49B}"/>
-          </ac:spMkLst>
-        </pc:spChg>
-        <pc:spChg chg="mod">
-          <ac:chgData name="ambleic@clemson.edu" userId="43615028507_tp_box_2" providerId="OAuth2" clId="{5F4B9ABB-DEB5-4DC3-A8F9-1752A2D02C85}" dt="2026-07-18T20:21:25.616" v="429"/>
-          <ac:spMkLst>
-            <pc:docMk/>
-            <pc:sldMk cId="0" sldId="274"/>
-            <ac:spMk id="42" creationId="{097E363A-9A4B-0E7B-C550-0550BDE18BAE}"/>
-          </ac:spMkLst>
-        </pc:spChg>
-        <pc:spChg chg="mod">
-          <ac:chgData name="ambleic@clemson.edu" userId="43615028507_tp_box_2" providerId="OAuth2" clId="{5F4B9ABB-DEB5-4DC3-A8F9-1752A2D02C85}" dt="2026-07-18T20:21:25.616" v="431"/>
-          <ac:spMkLst>
-            <pc:docMk/>
-            <pc:sldMk cId="0" sldId="274"/>
-            <ac:spMk id="43" creationId="{ABCB3DCD-3DAA-3B0C-0C88-4EB93C1D627D}"/>
-          </ac:spMkLst>
-        </pc:spChg>
-        <pc:spChg chg="mod">
-          <ac:chgData name="ambleic@clemson.edu" userId="43615028507_tp_box_2" providerId="OAuth2" clId="{5F4B9ABB-DEB5-4DC3-A8F9-1752A2D02C85}" dt="2026-07-18T20:21:25.616" v="430"/>
-          <ac:spMkLst>
-            <pc:docMk/>
-            <pc:sldMk cId="0" sldId="274"/>
-            <ac:spMk id="44" creationId="{B61F5979-6DA4-A4AB-B2DF-72B797A21A0E}"/>
-          </ac:spMkLst>
-        </pc:spChg>
-        <pc:spChg chg="mod">
-          <ac:chgData name="ambleic@clemson.edu" userId="43615028507_tp_box_2" providerId="OAuth2" clId="{5F4B9ABB-DEB5-4DC3-A8F9-1752A2D02C85}" dt="2026-07-18T20:21:25.618" v="436"/>
-          <ac:spMkLst>
-            <pc:docMk/>
-            <pc:sldMk cId="0" sldId="274"/>
-            <ac:spMk id="46" creationId="{4A5A1607-FFF6-530D-D63F-6595DE536723}"/>
-          </ac:spMkLst>
-        </pc:spChg>
-        <pc:spChg chg="mod">
-          <ac:chgData name="ambleic@clemson.edu" userId="43615028507_tp_box_2" providerId="OAuth2" clId="{5F4B9ABB-DEB5-4DC3-A8F9-1752A2D02C85}" dt="2026-07-18T20:21:25.619" v="438"/>
-          <ac:spMkLst>
-            <pc:docMk/>
-            <pc:sldMk cId="0" sldId="274"/>
-            <ac:spMk id="47" creationId="{26C5C571-55C4-AC16-70AF-A14E4E267ECA}"/>
-          </ac:spMkLst>
-        </pc:spChg>
-        <pc:spChg chg="mod">
-          <ac:chgData name="ambleic@clemson.edu" userId="43615028507_tp_box_2" providerId="OAuth2" clId="{5F4B9ABB-DEB5-4DC3-A8F9-1752A2D02C85}" dt="2026-07-18T20:21:25.618" v="437"/>
-          <ac:spMkLst>
-            <pc:docMk/>
-            <pc:sldMk cId="0" sldId="274"/>
-            <ac:spMk id="48" creationId="{73AD04A0-8B39-C652-FF97-BA9E600F89A5}"/>
-          </ac:spMkLst>
-        </pc:spChg>
-        <pc:spChg chg="mod">
-          <ac:chgData name="ambleic@clemson.edu" userId="43615028507_tp_box_2" providerId="OAuth2" clId="{5F4B9ABB-DEB5-4DC3-A8F9-1752A2D02C85}" dt="2026-07-18T20:21:25.621" v="443"/>
-          <ac:spMkLst>
-            <pc:docMk/>
-            <pc:sldMk cId="0" sldId="274"/>
-            <ac:spMk id="50" creationId="{B484E23B-F0DA-0576-1B3E-86BA289BD01D}"/>
-          </ac:spMkLst>
-        </pc:spChg>
-        <pc:spChg chg="mod">
-          <ac:chgData name="ambleic@clemson.edu" userId="43615028507_tp_box_2" providerId="OAuth2" clId="{5F4B9ABB-DEB5-4DC3-A8F9-1752A2D02C85}" dt="2026-07-18T20:21:25.621" v="445"/>
-          <ac:spMkLst>
-            <pc:docMk/>
-            <pc:sldMk cId="0" sldId="274"/>
-            <ac:spMk id="51" creationId="{168A532D-AF7D-C4E5-E01F-93AA4ADECD8A}"/>
-          </ac:spMkLst>
-        </pc:spChg>
-        <pc:spChg chg="mod">
-          <ac:chgData name="ambleic@clemson.edu" userId="43615028507_tp_box_2" providerId="OAuth2" clId="{5F4B9ABB-DEB5-4DC3-A8F9-1752A2D02C85}" dt="2026-07-18T20:21:25.621" v="444"/>
-          <ac:spMkLst>
-            <pc:docMk/>
-            <pc:sldMk cId="0" sldId="274"/>
-            <ac:spMk id="52" creationId="{19026C34-9F89-D816-7B27-E69A5724D828}"/>
-          </ac:spMkLst>
-        </pc:spChg>
-        <pc:spChg chg="mod">
-          <ac:chgData name="ambleic@clemson.edu" userId="43615028507_tp_box_2" providerId="OAuth2" clId="{5F4B9ABB-DEB5-4DC3-A8F9-1752A2D02C85}" dt="2026-07-18T20:17:45.319" v="403" actId="255"/>
-          <ac:spMkLst>
-            <pc:docMk/>
-            <pc:sldMk cId="0" sldId="274"/>
-            <ac:spMk id="53" creationId="{A887FBE7-EB77-046D-6D1E-A1E7CB5C3444}"/>
-          </ac:spMkLst>
-        </pc:spChg>
-        <pc:spChg chg="mod">
-          <ac:chgData name="ambleic@clemson.edu" userId="43615028507_tp_box_2" providerId="OAuth2" clId="{5F4B9ABB-DEB5-4DC3-A8F9-1752A2D02C85}" dt="2026-07-18T20:17:45.319" v="403" actId="255"/>
-          <ac:spMkLst>
-            <pc:docMk/>
-            <pc:sldMk cId="0" sldId="274"/>
-            <ac:spMk id="54" creationId="{4159EFA9-734E-4E0E-A050-C782A0846E60}"/>
-          </ac:spMkLst>
-        </pc:spChg>
-        <pc:spChg chg="mod">
-          <ac:chgData name="ambleic@clemson.edu" userId="43615028507_tp_box_2" providerId="OAuth2" clId="{5F4B9ABB-DEB5-4DC3-A8F9-1752A2D02C85}" dt="2026-07-18T20:17:45.319" v="403" actId="255"/>
-          <ac:spMkLst>
-            <pc:docMk/>
-            <pc:sldMk cId="0" sldId="274"/>
-            <ac:spMk id="58" creationId="{E21728D9-63E9-D080-5423-C1E6345A9E30}"/>
-          </ac:spMkLst>
-        </pc:spChg>
-        <pc:spChg chg="mod">
-          <ac:chgData name="ambleic@clemson.edu" userId="43615028507_tp_box_2" providerId="OAuth2" clId="{5F4B9ABB-DEB5-4DC3-A8F9-1752A2D02C85}" dt="2026-07-18T20:17:45.319" v="403" actId="255"/>
-          <ac:spMkLst>
-            <pc:docMk/>
-            <pc:sldMk cId="0" sldId="274"/>
-            <ac:spMk id="59" creationId="{DF703E20-53BC-6FF1-0ECF-F624B8DA98F0}"/>
-          </ac:spMkLst>
-        </pc:spChg>
-      </pc:sldChg>
       <pc:sldChg chg="modSp mod modNotesTx">
         <pc:chgData name="ambleic@clemson.edu" userId="43615028507_tp_box_2" providerId="OAuth2" clId="{5F4B9ABB-DEB5-4DC3-A8F9-1752A2D02C85}" dt="2026-07-19T04:36:26.387" v="1088" actId="20577"/>
         <pc:sldMkLst>
@@ -411,13 +219,6 @@
           </ac:spMkLst>
         </pc:spChg>
       </pc:sldChg>
-      <pc:sldChg chg="modSp del mod ord">
-        <pc:chgData name="ambleic@clemson.edu" userId="43615028507_tp_box_2" providerId="OAuth2" clId="{5F4B9ABB-DEB5-4DC3-A8F9-1752A2D02C85}" dt="2026-07-18T20:03:46.543" v="233" actId="47"/>
-        <pc:sldMkLst>
-          <pc:docMk/>
-          <pc:sldMk cId="3159209876" sldId="308"/>
-        </pc:sldMkLst>
-      </pc:sldChg>
       <pc:sldChg chg="modSp mod">
         <pc:chgData name="ambleic@clemson.edu" userId="43615028507_tp_box_2" providerId="OAuth2" clId="{5F4B9ABB-DEB5-4DC3-A8F9-1752A2D02C85}" dt="2026-07-19T04:35:40.575" v="1085" actId="20577"/>
         <pc:sldMkLst>
@@ -433,20 +234,6 @@
           </ac:spMkLst>
         </pc:spChg>
       </pc:sldChg>
-      <pc:sldChg chg="modSp del mod">
-        <pc:chgData name="ambleic@clemson.edu" userId="43615028507_tp_box_2" providerId="OAuth2" clId="{5F4B9ABB-DEB5-4DC3-A8F9-1752A2D02C85}" dt="2026-07-18T20:02:03.368" v="228" actId="47"/>
-        <pc:sldMkLst>
-          <pc:docMk/>
-          <pc:sldMk cId="1089057907" sldId="407"/>
-        </pc:sldMkLst>
-      </pc:sldChg>
-      <pc:sldChg chg="modSp add del mod">
-        <pc:chgData name="ambleic@clemson.edu" userId="43615028507_tp_box_2" providerId="OAuth2" clId="{5F4B9ABB-DEB5-4DC3-A8F9-1752A2D02C85}" dt="2026-07-18T20:02:09.494" v="231" actId="47"/>
-        <pc:sldMkLst>
-          <pc:docMk/>
-          <pc:sldMk cId="1869251149" sldId="408"/>
-        </pc:sldMkLst>
-      </pc:sldChg>
       <pc:sldChg chg="modSp">
         <pc:chgData name="ambleic@clemson.edu" userId="43615028507_tp_box_2" providerId="OAuth2" clId="{5F4B9ABB-DEB5-4DC3-A8F9-1752A2D02C85}" dt="2026-07-18T20:56:09.255" v="1013" actId="20577"/>
         <pc:sldMkLst>
@@ -459,21 +246,6 @@
             <pc:docMk/>
             <pc:sldMk cId="3782569830" sldId="409"/>
             <ac:spMk id="5" creationId="{F31F4AF8-58E5-1142-92E4-5C4BF9F42DD6}"/>
-          </ac:spMkLst>
-        </pc:spChg>
-      </pc:sldChg>
-      <pc:sldChg chg="modSp del">
-        <pc:chgData name="ambleic@clemson.edu" userId="43615028507_tp_box_2" providerId="OAuth2" clId="{5F4B9ABB-DEB5-4DC3-A8F9-1752A2D02C85}" dt="2026-07-18T20:40:25.474" v="667"/>
-        <pc:sldMkLst>
-          <pc:docMk/>
-          <pc:sldMk cId="1663621628" sldId="416"/>
-        </pc:sldMkLst>
-        <pc:spChg chg="mod">
-          <ac:chgData name="ambleic@clemson.edu" userId="43615028507_tp_box_2" providerId="OAuth2" clId="{5F4B9ABB-DEB5-4DC3-A8F9-1752A2D02C85}" dt="2026-07-18T20:39:41.831" v="665" actId="20577"/>
-          <ac:spMkLst>
-            <pc:docMk/>
-            <pc:sldMk cId="1663621628" sldId="416"/>
-            <ac:spMk id="21" creationId="{3C38A973-21C1-C28F-0F8E-758B0F44D030}"/>
           </ac:spMkLst>
         </pc:spChg>
       </pc:sldChg>
@@ -491,29 +263,6 @@
             <ac:picMk id="3" creationId="{C9FAD540-9060-126D-3955-CA7485295114}"/>
           </ac:picMkLst>
         </pc:picChg>
-        <pc:picChg chg="del">
-          <ac:chgData name="ambleic@clemson.edu" userId="43615028507_tp_box_2" providerId="OAuth2" clId="{5F4B9ABB-DEB5-4DC3-A8F9-1752A2D02C85}" dt="2026-07-18T22:09:10.196" v="1073" actId="478"/>
-          <ac:picMkLst>
-            <pc:docMk/>
-            <pc:sldMk cId="1629276906" sldId="419"/>
-            <ac:picMk id="3" creationId="{EEE2FAEF-8B1B-7D63-5372-163E0D3ECF25}"/>
-          </ac:picMkLst>
-        </pc:picChg>
-        <pc:picChg chg="add del mod">
-          <ac:chgData name="ambleic@clemson.edu" userId="43615028507_tp_box_2" providerId="OAuth2" clId="{5F4B9ABB-DEB5-4DC3-A8F9-1752A2D02C85}" dt="2026-07-19T04:24:55.249" v="1076" actId="478"/>
-          <ac:picMkLst>
-            <pc:docMk/>
-            <pc:sldMk cId="1629276906" sldId="419"/>
-            <ac:picMk id="5" creationId="{279562D2-4A39-F8BF-3445-A259748F59C8}"/>
-          </ac:picMkLst>
-        </pc:picChg>
-      </pc:sldChg>
-      <pc:sldChg chg="del">
-        <pc:chgData name="ambleic@clemson.edu" userId="43615028507_tp_box_2" providerId="OAuth2" clId="{5F4B9ABB-DEB5-4DC3-A8F9-1752A2D02C85}" dt="2026-07-18T20:01:52.163" v="223" actId="47"/>
-        <pc:sldMkLst>
-          <pc:docMk/>
-          <pc:sldMk cId="1833375455" sldId="421"/>
-        </pc:sldMkLst>
       </pc:sldChg>
       <pc:sldChg chg="add">
         <pc:chgData name="ambleic@clemson.edu" userId="43615028507_tp_box_2" providerId="OAuth2" clId="{5F4B9ABB-DEB5-4DC3-A8F9-1752A2D02C85}" dt="2026-07-18T20:01:48.706" v="222"/>
@@ -523,13 +272,13 @@
         </pc:sldMkLst>
       </pc:sldChg>
       <pc:sldChg chg="modSp add mod ord">
-        <pc:chgData name="ambleic@clemson.edu" userId="43615028507_tp_box_2" providerId="OAuth2" clId="{5F4B9ABB-DEB5-4DC3-A8F9-1752A2D02C85}" dt="2026-07-18T20:55:22.063" v="985" actId="20577"/>
+        <pc:chgData name="ambleic@clemson.edu" userId="43615028507_tp_box_2" providerId="OAuth2" clId="{5F4B9ABB-DEB5-4DC3-A8F9-1752A2D02C85}" dt="2026-07-21T20:02:21.800" v="1089"/>
         <pc:sldMkLst>
           <pc:docMk/>
           <pc:sldMk cId="3886218017" sldId="426"/>
         </pc:sldMkLst>
         <pc:spChg chg="mod">
-          <ac:chgData name="ambleic@clemson.edu" userId="43615028507_tp_box_2" providerId="OAuth2" clId="{5F4B9ABB-DEB5-4DC3-A8F9-1752A2D02C85}" dt="2026-07-18T20:55:22.063" v="985" actId="20577"/>
+          <ac:chgData name="ambleic@clemson.edu" userId="43615028507_tp_box_2" providerId="OAuth2" clId="{5F4B9ABB-DEB5-4DC3-A8F9-1752A2D02C85}" dt="2026-07-21T20:02:21.800" v="1089"/>
           <ac:spMkLst>
             <pc:docMk/>
             <pc:sldMk cId="3886218017" sldId="426"/>
@@ -552,72 +301,6 @@
             <ac:spMk id="84" creationId="{457AC859-6DCC-BE97-86ED-E048D25F6114}"/>
           </ac:spMkLst>
         </pc:spChg>
-      </pc:sldChg>
-      <pc:sldChg chg="add del">
-        <pc:chgData name="ambleic@clemson.edu" userId="43615028507_tp_box_2" providerId="OAuth2" clId="{5F4B9ABB-DEB5-4DC3-A8F9-1752A2D02C85}" dt="2026-07-18T20:04:09.393" v="270"/>
-        <pc:sldMkLst>
-          <pc:docMk/>
-          <pc:sldMk cId="657207687" sldId="502"/>
-        </pc:sldMkLst>
-      </pc:sldChg>
-      <pc:sldChg chg="add del">
-        <pc:chgData name="ambleic@clemson.edu" userId="43615028507_tp_box_2" providerId="OAuth2" clId="{5F4B9ABB-DEB5-4DC3-A8F9-1752A2D02C85}" dt="2026-07-18T20:09:56.529" v="318"/>
-        <pc:sldMkLst>
-          <pc:docMk/>
-          <pc:sldMk cId="1669003075" sldId="503"/>
-        </pc:sldMkLst>
-      </pc:sldChg>
-      <pc:sldChg chg="add del">
-        <pc:chgData name="ambleic@clemson.edu" userId="43615028507_tp_box_2" providerId="OAuth2" clId="{5F4B9ABB-DEB5-4DC3-A8F9-1752A2D02C85}" dt="2026-07-18T20:16:56.098" v="397"/>
-        <pc:sldMkLst>
-          <pc:docMk/>
-          <pc:sldMk cId="4035965665" sldId="505"/>
-        </pc:sldMkLst>
-      </pc:sldChg>
-      <pc:sldChg chg="modSp add del mod ord">
-        <pc:chgData name="ambleic@clemson.edu" userId="43615028507_tp_box_2" providerId="OAuth2" clId="{5F4B9ABB-DEB5-4DC3-A8F9-1752A2D02C85}" dt="2026-07-18T20:05:46.833" v="284"/>
-        <pc:sldMkLst>
-          <pc:docMk/>
-          <pc:sldMk cId="2302341216" sldId="506"/>
-        </pc:sldMkLst>
-        <pc:graphicFrameChg chg="modGraphic">
-          <ac:chgData name="ambleic@clemson.edu" userId="43615028507_tp_box_2" providerId="OAuth2" clId="{5F4B9ABB-DEB5-4DC3-A8F9-1752A2D02C85}" dt="2026-07-18T20:04:09.417" v="278"/>
-          <ac:graphicFrameMkLst>
-            <pc:docMk/>
-            <pc:sldMk cId="2302341216" sldId="506"/>
-            <ac:graphicFrameMk id="7" creationId="{67FA3C47-38BF-4381-9A13-2A6F8DC32BCE}"/>
-          </ac:graphicFrameMkLst>
-        </pc:graphicFrameChg>
-      </pc:sldChg>
-      <pc:sldChg chg="modSp add del mod ord">
-        <pc:chgData name="ambleic@clemson.edu" userId="43615028507_tp_box_2" providerId="OAuth2" clId="{5F4B9ABB-DEB5-4DC3-A8F9-1752A2D02C85}" dt="2026-07-18T20:07:14.776" v="296"/>
-        <pc:sldMkLst>
-          <pc:docMk/>
-          <pc:sldMk cId="2850977925" sldId="507"/>
-        </pc:sldMkLst>
-        <pc:graphicFrameChg chg="modGraphic">
-          <ac:chgData name="ambleic@clemson.edu" userId="43615028507_tp_box_2" providerId="OAuth2" clId="{5F4B9ABB-DEB5-4DC3-A8F9-1752A2D02C85}" dt="2026-07-18T20:05:46.874" v="292"/>
-          <ac:graphicFrameMkLst>
-            <pc:docMk/>
-            <pc:sldMk cId="2850977925" sldId="507"/>
-            <ac:graphicFrameMk id="7" creationId="{67FA3C47-38BF-4381-9A13-2A6F8DC32BCE}"/>
-          </ac:graphicFrameMkLst>
-        </pc:graphicFrameChg>
-      </pc:sldChg>
-      <pc:sldChg chg="modSp add del mod">
-        <pc:chgData name="ambleic@clemson.edu" userId="43615028507_tp_box_2" providerId="OAuth2" clId="{5F4B9ABB-DEB5-4DC3-A8F9-1752A2D02C85}" dt="2026-07-18T20:53:21.474" v="948"/>
-        <pc:sldMkLst>
-          <pc:docMk/>
-          <pc:sldMk cId="3930212255" sldId="508"/>
-        </pc:sldMkLst>
-        <pc:graphicFrameChg chg="mod modGraphic">
-          <ac:chgData name="ambleic@clemson.edu" userId="43615028507_tp_box_2" providerId="OAuth2" clId="{5F4B9ABB-DEB5-4DC3-A8F9-1752A2D02C85}" dt="2026-07-18T20:07:33.364" v="316" actId="1035"/>
-          <ac:graphicFrameMkLst>
-            <pc:docMk/>
-            <pc:sldMk cId="3930212255" sldId="508"/>
-            <ac:graphicFrameMk id="7" creationId="{67FA3C47-38BF-4381-9A13-2A6F8DC32BCE}"/>
-          </ac:graphicFrameMkLst>
-        </pc:graphicFrameChg>
       </pc:sldChg>
       <pc:sldChg chg="modSp add mod">
         <pc:chgData name="ambleic@clemson.edu" userId="43615028507_tp_box_2" providerId="OAuth2" clId="{5F4B9ABB-DEB5-4DC3-A8F9-1752A2D02C85}" dt="2026-07-18T20:16:47.285" v="395" actId="12788"/>
@@ -1029,7 +712,7 @@
           <a:p>
             <a:fld id="{BA3813FC-438F-41C6-BA17-82A754B920B0}" type="datetimeFigureOut">
               <a:rPr lang="en-US" smtClean="0"/>
-              <a:t>7/19/2026</a:t>
+              <a:t>7/21/2026</a:t>
             </a:fld>
             <a:endParaRPr lang="en-US"/>
           </a:p>
@@ -2415,7 +2098,7 @@
           <a:p>
             <a:fld id="{01365F07-267D-4BA2-BC6C-B3B81FF729D9}" type="datetimeFigureOut">
               <a:rPr lang="en-US" smtClean="0"/>
-              <a:t>7/19/2026</a:t>
+              <a:t>7/21/2026</a:t>
             </a:fld>
             <a:endParaRPr lang="en-US"/>
           </a:p>
@@ -2613,7 +2296,7 @@
           <a:p>
             <a:fld id="{01365F07-267D-4BA2-BC6C-B3B81FF729D9}" type="datetimeFigureOut">
               <a:rPr lang="en-US" smtClean="0"/>
-              <a:t>7/19/2026</a:t>
+              <a:t>7/21/2026</a:t>
             </a:fld>
             <a:endParaRPr lang="en-US"/>
           </a:p>
@@ -2821,7 +2504,7 @@
           <a:p>
             <a:fld id="{01365F07-267D-4BA2-BC6C-B3B81FF729D9}" type="datetimeFigureOut">
               <a:rPr lang="en-US" smtClean="0"/>
-              <a:t>7/19/2026</a:t>
+              <a:t>7/21/2026</a:t>
             </a:fld>
             <a:endParaRPr lang="en-US"/>
           </a:p>
@@ -3054,7 +2737,7 @@
           <a:p>
             <a:fld id="{01365F07-267D-4BA2-BC6C-B3B81FF729D9}" type="datetimeFigureOut">
               <a:rPr lang="en-US" smtClean="0"/>
-              <a:t>7/19/2026</a:t>
+              <a:t>7/21/2026</a:t>
             </a:fld>
             <a:endParaRPr lang="en-US"/>
           </a:p>
@@ -3329,7 +3012,7 @@
           <a:p>
             <a:fld id="{01365F07-267D-4BA2-BC6C-B3B81FF729D9}" type="datetimeFigureOut">
               <a:rPr lang="en-US" smtClean="0"/>
-              <a:t>7/19/2026</a:t>
+              <a:t>7/21/2026</a:t>
             </a:fld>
             <a:endParaRPr lang="en-US"/>
           </a:p>
@@ -3594,7 +3277,7 @@
           <a:p>
             <a:fld id="{01365F07-267D-4BA2-BC6C-B3B81FF729D9}" type="datetimeFigureOut">
               <a:rPr lang="en-US" smtClean="0"/>
-              <a:t>7/19/2026</a:t>
+              <a:t>7/21/2026</a:t>
             </a:fld>
             <a:endParaRPr lang="en-US"/>
           </a:p>
@@ -4006,7 +3689,7 @@
           <a:p>
             <a:fld id="{01365F07-267D-4BA2-BC6C-B3B81FF729D9}" type="datetimeFigureOut">
               <a:rPr lang="en-US" smtClean="0"/>
-              <a:t>7/19/2026</a:t>
+              <a:t>7/21/2026</a:t>
             </a:fld>
             <a:endParaRPr lang="en-US"/>
           </a:p>
@@ -4147,7 +3830,7 @@
           <a:p>
             <a:fld id="{01365F07-267D-4BA2-BC6C-B3B81FF729D9}" type="datetimeFigureOut">
               <a:rPr lang="en-US" smtClean="0"/>
-              <a:t>7/19/2026</a:t>
+              <a:t>7/21/2026</a:t>
             </a:fld>
             <a:endParaRPr lang="en-US"/>
           </a:p>
@@ -4260,7 +3943,7 @@
           <a:p>
             <a:fld id="{01365F07-267D-4BA2-BC6C-B3B81FF729D9}" type="datetimeFigureOut">
               <a:rPr lang="en-US" smtClean="0"/>
-              <a:t>7/19/2026</a:t>
+              <a:t>7/21/2026</a:t>
             </a:fld>
             <a:endParaRPr lang="en-US"/>
           </a:p>
@@ -4571,7 +4254,7 @@
           <a:p>
             <a:fld id="{01365F07-267D-4BA2-BC6C-B3B81FF729D9}" type="datetimeFigureOut">
               <a:rPr lang="en-US" smtClean="0"/>
-              <a:t>7/19/2026</a:t>
+              <a:t>7/21/2026</a:t>
             </a:fld>
             <a:endParaRPr lang="en-US"/>
           </a:p>
@@ -4859,7 +4542,7 @@
           <a:p>
             <a:fld id="{01365F07-267D-4BA2-BC6C-B3B81FF729D9}" type="datetimeFigureOut">
               <a:rPr lang="en-US" smtClean="0"/>
-              <a:t>7/19/2026</a:t>
+              <a:t>7/21/2026</a:t>
             </a:fld>
             <a:endParaRPr lang="en-US"/>
           </a:p>
@@ -5100,7 +4783,7 @@
           <a:p>
             <a:fld id="{01365F07-267D-4BA2-BC6C-B3B81FF729D9}" type="datetimeFigureOut">
               <a:rPr lang="en-US" smtClean="0"/>
-              <a:t>7/19/2026</a:t>
+              <a:t>7/21/2026</a:t>
             </a:fld>
             <a:endParaRPr lang="en-US"/>
           </a:p>
@@ -12289,7 +11972,7 @@
                 <a:ea typeface="Trebuchet MS" pitchFamily="34" charset="-122"/>
                 <a:cs typeface="Arial" panose="020B0604020202020204" pitchFamily="34" charset="0"/>
               </a:rPr>
-              <a:t>Incremental Revisions</a:t>
+              <a:t>Refinement</a:t>
             </a:r>
           </a:p>
         </p:txBody>

</xml_diff>